<commit_message>
Update Day_03_Slides.pptx and add Office temp file
Week_01/Day_03/Slides/~$Day_03_Slides.pptx  updates answers
</commit_message>
<xml_diff>
--- a/Week_01/Day_03/Slides/Day_03_Slides.pptx
+++ b/Week_01/Day_03/Slides/Day_03_Slides.pptx
@@ -184,6 +184,11 @@
       </a:defRPr>
     </a:lvl9pPr>
   </p:defaultTextStyle>
+  <p:extLst>
+    <p:ext uri="{EFAFB233-063F-42B5-8137-9DF3F51BA10A}">
+      <p15:sldGuideLst xmlns:p15="http://schemas.microsoft.com/office/powerpoint/2012/main"/>
+    </p:ext>
+  </p:extLst>
 </p:presentation>
 </file>
 
@@ -16874,7 +16879,7 @@
         </p:nvSpPr>
         <p:spPr>
           <a:xfrm>
-            <a:off x="5669280" y="1280160"/>
+            <a:off x="5669280" y="1287975"/>
             <a:ext cx="3199680" cy="2559600"/>
           </a:xfrm>
           <a:prstGeom prst="rect">
@@ -16909,7 +16914,7 @@
               </a:lnSpc>
             </a:pPr>
             <a:r>
-              <a:rPr lang="en-US" sz="1100" b="1" u="none" strike="noStrike">
+              <a:rPr lang="en-US" sz="1100" b="1" u="none" strike="noStrike" dirty="0">
                 <a:solidFill>
                   <a:srgbClr val="2F5597"/>
                 </a:solidFill>
@@ -16917,9 +16922,31 @@
                 <a:uFillTx/>
                 <a:latin typeface="Calibri"/>
               </a:rPr>
-              <a:t>Q1. Which assignment strategy minimises disruption during rebalances?</a:t>
-            </a:r>
-            <a:endParaRPr lang="en-IN" sz="1100" b="0" u="none" strike="noStrike">
+              <a:t>Q1. Which assignment strategy </a:t>
+            </a:r>
+            <a:r>
+              <a:rPr lang="en-US" sz="1100" b="1" u="none" strike="noStrike" dirty="0" err="1">
+                <a:solidFill>
+                  <a:srgbClr val="2F5597"/>
+                </a:solidFill>
+                <a:effectLst/>
+                <a:uFillTx/>
+                <a:latin typeface="Calibri"/>
+              </a:rPr>
+              <a:t>minimises</a:t>
+            </a:r>
+            <a:r>
+              <a:rPr lang="en-US" sz="1100" b="1" u="none" strike="noStrike" dirty="0">
+                <a:solidFill>
+                  <a:srgbClr val="2F5597"/>
+                </a:solidFill>
+                <a:effectLst/>
+                <a:uFillTx/>
+                <a:latin typeface="Calibri"/>
+              </a:rPr>
+              <a:t> disruption during rebalances?</a:t>
+            </a:r>
+            <a:endParaRPr lang="en-IN" sz="1100" b="0" u="none" strike="noStrike" dirty="0">
               <a:solidFill>
                 <a:srgbClr val="000000"/>
               </a:solidFill>
@@ -16938,7 +16965,7 @@
               </a:tabLst>
             </a:pPr>
             <a:r>
-              <a:rPr lang="en-US" sz="1000" b="0" u="none" strike="noStrike">
+              <a:rPr lang="en-US" sz="1000" b="0" u="none" strike="noStrike" dirty="0">
                 <a:solidFill>
                   <a:srgbClr val="385170"/>
                 </a:solidFill>
@@ -16948,7 +16975,7 @@
               </a:rPr>
               <a:t>a) Range</a:t>
             </a:r>
-            <a:endParaRPr lang="en-IN" sz="1000" b="0" u="none" strike="noStrike">
+            <a:endParaRPr lang="en-IN" sz="1000" b="0" u="none" strike="noStrike" dirty="0">
               <a:solidFill>
                 <a:srgbClr val="000000"/>
               </a:solidFill>
@@ -16967,7 +16994,7 @@
               </a:tabLst>
             </a:pPr>
             <a:r>
-              <a:rPr lang="en-US" sz="1000" b="0" u="none" strike="noStrike">
+              <a:rPr lang="en-US" sz="1000" b="0" u="none" strike="noStrike" dirty="0">
                 <a:solidFill>
                   <a:srgbClr val="385170"/>
                 </a:solidFill>
@@ -16977,7 +17004,7 @@
               </a:rPr>
               <a:t>b) Round‑Robin</a:t>
             </a:r>
-            <a:endParaRPr lang="en-IN" sz="1000" b="0" u="none" strike="noStrike">
+            <a:endParaRPr lang="en-IN" sz="1000" b="0" u="none" strike="noStrike" dirty="0">
               <a:solidFill>
                 <a:srgbClr val="000000"/>
               </a:solidFill>
@@ -16996,7 +17023,7 @@
               </a:tabLst>
             </a:pPr>
             <a:r>
-              <a:rPr lang="en-US" sz="1000" b="0" u="none" strike="noStrike">
+              <a:rPr lang="en-US" sz="1000" b="0" u="none" strike="noStrike" dirty="0">
                 <a:solidFill>
                   <a:srgbClr val="385170"/>
                 </a:solidFill>
@@ -17006,7 +17033,7 @@
               </a:rPr>
               <a:t>c) Sticky</a:t>
             </a:r>
-            <a:endParaRPr lang="en-IN" sz="1000" b="0" u="none" strike="noStrike">
+            <a:endParaRPr lang="en-IN" sz="1000" b="0" u="none" strike="noStrike" dirty="0">
               <a:solidFill>
                 <a:srgbClr val="000000"/>
               </a:solidFill>
@@ -17025,7 +17052,7 @@
               </a:tabLst>
             </a:pPr>
             <a:r>
-              <a:rPr lang="en-US" sz="1000" b="0" u="none" strike="noStrike">
+              <a:rPr lang="en-US" sz="1000" b="0" u="none" strike="noStrike" dirty="0">
                 <a:solidFill>
                   <a:srgbClr val="385170"/>
                 </a:solidFill>
@@ -17035,7 +17062,7 @@
               </a:rPr>
               <a:t>d) Cooperative Sticky</a:t>
             </a:r>
-            <a:endParaRPr lang="en-IN" sz="1000" b="0" u="none" strike="noStrike">
+            <a:endParaRPr lang="en-IN" sz="1000" b="0" u="none" strike="noStrike" dirty="0">
               <a:solidFill>
                 <a:srgbClr val="000000"/>
               </a:solidFill>
@@ -17053,7 +17080,7 @@
                 <a:tab pos="0" algn="l"/>
               </a:tabLst>
             </a:pPr>
-            <a:endParaRPr lang="en-IN" sz="1100" b="0" u="none" strike="noStrike">
+            <a:endParaRPr lang="en-IN" sz="1100" b="0" u="none" strike="noStrike" dirty="0">
               <a:solidFill>
                 <a:srgbClr val="000000"/>
               </a:solidFill>
@@ -17071,7 +17098,7 @@
                 <a:tab pos="0" algn="l"/>
               </a:tabLst>
             </a:pPr>
-            <a:endParaRPr lang="en-IN" sz="1100" b="0" u="none" strike="noStrike">
+            <a:endParaRPr lang="en-IN" sz="1100" b="0" u="none" strike="noStrike" dirty="0">
               <a:solidFill>
                 <a:srgbClr val="000000"/>
               </a:solidFill>
@@ -17090,7 +17117,7 @@
               </a:tabLst>
             </a:pPr>
             <a:r>
-              <a:rPr lang="en-US" sz="1100" b="1" u="none" strike="noStrike">
+              <a:rPr lang="en-US" sz="1100" b="1" u="none" strike="noStrike" dirty="0">
                 <a:solidFill>
                   <a:srgbClr val="2F5597"/>
                 </a:solidFill>
@@ -17100,7 +17127,7 @@
               </a:rPr>
               <a:t>Q2. To avoid unnecessary rebalances on pod restarts, which property should you configure?</a:t>
             </a:r>
-            <a:endParaRPr lang="en-IN" sz="1100" b="0" u="none" strike="noStrike">
+            <a:endParaRPr lang="en-IN" sz="1100" b="0" u="none" strike="noStrike" dirty="0">
               <a:solidFill>
                 <a:srgbClr val="000000"/>
               </a:solidFill>
@@ -17119,7 +17146,7 @@
               </a:tabLst>
             </a:pPr>
             <a:r>
-              <a:rPr lang="en-US" sz="1000" b="0" u="none" strike="noStrike">
+              <a:rPr lang="en-US" sz="1000" b="0" u="none" strike="noStrike" dirty="0">
                 <a:solidFill>
                   <a:srgbClr val="385170"/>
                 </a:solidFill>
@@ -17129,7 +17156,7 @@
               </a:rPr>
               <a:t>a) session.timeout.ms</a:t>
             </a:r>
-            <a:endParaRPr lang="en-IN" sz="1000" b="0" u="none" strike="noStrike">
+            <a:endParaRPr lang="en-IN" sz="1000" b="0" u="none" strike="noStrike" dirty="0">
               <a:solidFill>
                 <a:srgbClr val="000000"/>
               </a:solidFill>
@@ -17148,7 +17175,7 @@
               </a:tabLst>
             </a:pPr>
             <a:r>
-              <a:rPr lang="en-US" sz="1000" b="0" u="none" strike="noStrike">
+              <a:rPr lang="en-US" sz="1000" b="0" u="none" strike="noStrike" dirty="0">
                 <a:solidFill>
                   <a:srgbClr val="385170"/>
                 </a:solidFill>
@@ -17158,7 +17185,7 @@
               </a:rPr>
               <a:t>b) group.instance.id</a:t>
             </a:r>
-            <a:endParaRPr lang="en-IN" sz="1000" b="0" u="none" strike="noStrike">
+            <a:endParaRPr lang="en-IN" sz="1000" b="0" u="none" strike="noStrike" dirty="0">
               <a:solidFill>
                 <a:srgbClr val="000000"/>
               </a:solidFill>
@@ -17177,7 +17204,7 @@
               </a:tabLst>
             </a:pPr>
             <a:r>
-              <a:rPr lang="en-US" sz="1000" b="0" u="none" strike="noStrike">
+              <a:rPr lang="en-US" sz="1000" b="0" u="none" strike="noStrike" dirty="0">
                 <a:solidFill>
                   <a:srgbClr val="385170"/>
                 </a:solidFill>
@@ -17187,7 +17214,7 @@
               </a:rPr>
               <a:t>c) max.poll.interval.ms</a:t>
             </a:r>
-            <a:endParaRPr lang="en-IN" sz="1000" b="0" u="none" strike="noStrike">
+            <a:endParaRPr lang="en-IN" sz="1000" b="0" u="none" strike="noStrike" dirty="0">
               <a:solidFill>
                 <a:srgbClr val="000000"/>
               </a:solidFill>
@@ -17206,7 +17233,7 @@
               </a:tabLst>
             </a:pPr>
             <a:r>
-              <a:rPr lang="en-US" sz="1000" b="0" u="none" strike="noStrike">
+              <a:rPr lang="en-US" sz="1000" b="0" u="none" strike="noStrike" dirty="0">
                 <a:solidFill>
                   <a:srgbClr val="385170"/>
                 </a:solidFill>
@@ -17214,9 +17241,20 @@
                 <a:uFillTx/>
                 <a:latin typeface="Calibri"/>
               </a:rPr>
-              <a:t>d) enable.idempotence</a:t>
-            </a:r>
-            <a:endParaRPr lang="en-IN" sz="1000" b="0" u="none" strike="noStrike">
+              <a:t>d) </a:t>
+            </a:r>
+            <a:r>
+              <a:rPr lang="en-US" sz="1000" b="0" u="none" strike="noStrike" dirty="0" err="1">
+                <a:solidFill>
+                  <a:srgbClr val="385170"/>
+                </a:solidFill>
+                <a:effectLst/>
+                <a:uFillTx/>
+                <a:latin typeface="Calibri"/>
+              </a:rPr>
+              <a:t>enable.idempotence</a:t>
+            </a:r>
+            <a:endParaRPr lang="en-IN" sz="1000" b="0" u="none" strike="noStrike" dirty="0">
               <a:solidFill>
                 <a:srgbClr val="000000"/>
               </a:solidFill>
@@ -17538,7 +17576,7 @@
         <p:spPr>
           <a:xfrm>
             <a:off x="640080" y="1234440"/>
-            <a:ext cx="7406280" cy="3245760"/>
+            <a:ext cx="7406280" cy="4522861"/>
           </a:xfrm>
           <a:prstGeom prst="rect">
             <a:avLst/>
@@ -17580,7 +17618,7 @@
               <a:buChar char=""/>
             </a:pPr>
             <a:r>
-              <a:rPr lang="en-US" sz="1500" b="0" u="none" strike="noStrike">
+              <a:rPr lang="en-US" sz="1500" b="0" u="none" strike="noStrike" dirty="0">
                 <a:solidFill>
                   <a:srgbClr val="1E1E1E"/>
                 </a:solidFill>
@@ -17590,7 +17628,7 @@
               </a:rPr>
               <a:t>With 6 partitions and 3 consumers in one group, each consumer can receive about 2 partitions.</a:t>
             </a:r>
-            <a:endParaRPr lang="en-IN" sz="1500" b="0" u="none" strike="noStrike">
+            <a:endParaRPr lang="en-IN" sz="1500" b="0" u="none" strike="noStrike" dirty="0">
               <a:solidFill>
                 <a:srgbClr val="000000"/>
               </a:solidFill>
@@ -17614,7 +17652,7 @@
               <a:buChar char=""/>
             </a:pPr>
             <a:r>
-              <a:rPr lang="en-US" sz="1500" b="0" u="none" strike="noStrike">
+              <a:rPr lang="en-US" sz="1500" b="0" u="none" strike="noStrike" dirty="0">
                 <a:solidFill>
                   <a:srgbClr val="1E1E1E"/>
                 </a:solidFill>
@@ -17624,7 +17662,7 @@
               </a:rPr>
               <a:t>A seventh consumer in the same group would be idle if the topic still has only 6 partitions.</a:t>
             </a:r>
-            <a:endParaRPr lang="en-IN" sz="1500" b="0" u="none" strike="noStrike">
+            <a:endParaRPr lang="en-IN" sz="1500" b="0" u="none" strike="noStrike" dirty="0">
               <a:solidFill>
                 <a:srgbClr val="000000"/>
               </a:solidFill>
@@ -17648,7 +17686,7 @@
               <a:buChar char=""/>
             </a:pPr>
             <a:r>
-              <a:rPr lang="en-US" sz="1500" b="0" u="none" strike="noStrike">
+              <a:rPr lang="en-US" sz="1500" b="0" u="none" strike="noStrike" dirty="0">
                 <a:solidFill>
                   <a:srgbClr val="1E1E1E"/>
                 </a:solidFill>
@@ -17658,7 +17696,7 @@
               </a:rPr>
               <a:t>Different group IDs are independent subscribers and each group keeps its own committed offsets.</a:t>
             </a:r>
-            <a:endParaRPr lang="en-IN" sz="1500" b="0" u="none" strike="noStrike">
+            <a:endParaRPr lang="en-IN" sz="1500" b="0" u="none" strike="noStrike" dirty="0">
               <a:solidFill>
                 <a:srgbClr val="000000"/>
               </a:solidFill>
@@ -17682,7 +17720,7 @@
               <a:buChar char=""/>
             </a:pPr>
             <a:r>
-              <a:rPr lang="en-US" sz="1500" b="0" u="none" strike="noStrike">
+              <a:rPr lang="en-US" sz="1500" b="0" u="none" strike="noStrike" dirty="0">
                 <a:solidFill>
                   <a:srgbClr val="1E1E1E"/>
                 </a:solidFill>
@@ -17692,7 +17730,82 @@
               </a:rPr>
               <a:t>Cooperative sticky assignment usually minimizes disruption during rebalances.</a:t>
             </a:r>
-            <a:endParaRPr lang="en-IN" sz="1500" b="0" u="none" strike="noStrike">
+          </a:p>
+          <a:p>
+            <a:r>
+              <a:rPr lang="en-IN" sz="1600" b="1" dirty="0"/>
+              <a:t>Q1. Which assignment strategy minimises disruption during rebalances?</a:t>
+            </a:r>
+            <a:br>
+              <a:rPr lang="en-IN" sz="1600" dirty="0"/>
+            </a:br>
+            <a:r>
+              <a:rPr lang="en-IN" sz="1600" b="1" dirty="0"/>
+              <a:t>d) Cooperative Sticky</a:t>
+            </a:r>
+            <a:endParaRPr lang="en-IN" sz="1600" dirty="0"/>
+          </a:p>
+          <a:p>
+            <a:r>
+              <a:rPr lang="en-IN" sz="1600" b="1" dirty="0"/>
+              <a:t>Cooperative Sticky</a:t>
+            </a:r>
+            <a:r>
+              <a:rPr lang="en-IN" sz="1600" dirty="0"/>
+              <a:t> rebalancing avoids stopping all consumers at once. It moves only the partitions that need to move, so disruption is minimal.</a:t>
+            </a:r>
+          </a:p>
+          <a:p>
+            <a:r>
+              <a:rPr lang="en-IN" sz="1600" b="1" dirty="0"/>
+              <a:t>Q2. To avoid unnecessary rebalances on pod restarts, which property should you configure?</a:t>
+            </a:r>
+            <a:br>
+              <a:rPr lang="en-IN" sz="1600" dirty="0"/>
+            </a:br>
+            <a:r>
+              <a:rPr lang="en-IN" sz="1600" b="1" dirty="0"/>
+              <a:t>b) </a:t>
+            </a:r>
+            <a:r>
+              <a:rPr lang="en-IN" b="1" dirty="0"/>
+              <a:t>group.instance.id</a:t>
+            </a:r>
+            <a:endParaRPr lang="en-IN" sz="1600" dirty="0"/>
+          </a:p>
+          <a:p>
+            <a:r>
+              <a:rPr lang="en-IN" dirty="0"/>
+              <a:t>group.instance.id</a:t>
+            </a:r>
+            <a:r>
+              <a:rPr lang="en-IN" sz="1600" dirty="0"/>
+              <a:t> enables </a:t>
+            </a:r>
+            <a:r>
+              <a:rPr lang="en-IN" sz="1600" b="1" dirty="0"/>
+              <a:t>static membership</a:t>
+            </a:r>
+            <a:r>
+              <a:rPr lang="en-IN" sz="1600" dirty="0"/>
+              <a:t>, so Kafka can recognize the same consumer instance after a restart and avoid unnecessary rebalances.</a:t>
+            </a:r>
+          </a:p>
+          <a:p>
+            <a:pPr marL="343080" indent="-171360" defTabSz="914400">
+              <a:lnSpc>
+                <a:spcPct val="100000"/>
+              </a:lnSpc>
+              <a:spcAft>
+                <a:spcPts val="601"/>
+              </a:spcAft>
+              <a:buClr>
+                <a:srgbClr val="1E1E1E"/>
+              </a:buClr>
+              <a:buFont typeface="Symbol" charset="2"/>
+              <a:buChar char=""/>
+            </a:pPr>
+            <a:endParaRPr lang="en-IN" sz="1500" b="0" u="none" strike="noStrike" dirty="0">
               <a:solidFill>
                 <a:srgbClr val="000000"/>
               </a:solidFill>
@@ -21170,7 +21283,7 @@
               </a:lnSpc>
             </a:pPr>
             <a:r>
-              <a:rPr lang="en-US" sz="1100" b="1" u="none" strike="noStrike">
+              <a:rPr lang="en-US" sz="1100" b="1" u="none" strike="noStrike" dirty="0">
                 <a:solidFill>
                   <a:srgbClr val="2F5597"/>
                 </a:solidFill>
@@ -21180,23 +21293,23 @@
               </a:rPr>
               <a:t>Q3. Where are committed offsets stored?</a:t>
             </a:r>
-            <a:endParaRPr lang="en-IN" sz="1100" b="0" u="none" strike="noStrike">
-              <a:solidFill>
-                <a:srgbClr val="000000"/>
-              </a:solidFill>
-              <a:effectLst/>
-              <a:uFillTx/>
-              <a:latin typeface="Arial"/>
-            </a:endParaRPr>
-          </a:p>
-          <a:p>
-            <a:pPr defTabSz="914400">
-              <a:lnSpc>
-                <a:spcPct val="100000"/>
-              </a:lnSpc>
-            </a:pPr>
-            <a:r>
-              <a:rPr lang="en-US" sz="1000" b="0" u="none" strike="noStrike">
+            <a:endParaRPr lang="en-IN" sz="1100" b="0" u="none" strike="noStrike" dirty="0">
+              <a:solidFill>
+                <a:srgbClr val="000000"/>
+              </a:solidFill>
+              <a:effectLst/>
+              <a:uFillTx/>
+              <a:latin typeface="Arial"/>
+            </a:endParaRPr>
+          </a:p>
+          <a:p>
+            <a:pPr defTabSz="914400">
+              <a:lnSpc>
+                <a:spcPct val="100000"/>
+              </a:lnSpc>
+            </a:pPr>
+            <a:r>
+              <a:rPr lang="en-US" sz="1000" b="0" u="none" strike="noStrike" dirty="0">
                 <a:solidFill>
                   <a:srgbClr val="385170"/>
                 </a:solidFill>
@@ -21204,25 +21317,10 @@
                 <a:uFillTx/>
                 <a:latin typeface="Calibri"/>
               </a:rPr>
-              <a:t>a) __consumer_offsets internal topic</a:t>
-            </a:r>
-            <a:endParaRPr lang="en-IN" sz="1000" b="0" u="none" strike="noStrike">
-              <a:solidFill>
-                <a:srgbClr val="000000"/>
-              </a:solidFill>
-              <a:effectLst/>
-              <a:uFillTx/>
-              <a:latin typeface="Arial"/>
-            </a:endParaRPr>
-          </a:p>
-          <a:p>
-            <a:pPr defTabSz="914400">
-              <a:lnSpc>
-                <a:spcPct val="100000"/>
-              </a:lnSpc>
-            </a:pPr>
-            <a:r>
-              <a:rPr lang="en-US" sz="1000" b="0" u="none" strike="noStrike">
+              <a:t>a) __</a:t>
+            </a:r>
+            <a:r>
+              <a:rPr lang="en-US" sz="1000" b="0" u="none" strike="noStrike" dirty="0" err="1">
                 <a:solidFill>
                   <a:srgbClr val="385170"/>
                 </a:solidFill>
@@ -21230,25 +21328,62 @@
                 <a:uFillTx/>
                 <a:latin typeface="Calibri"/>
               </a:rPr>
+              <a:t>consumer_offsets</a:t>
+            </a:r>
+            <a:r>
+              <a:rPr lang="en-US" sz="1000" b="0" u="none" strike="noStrike" dirty="0">
+                <a:solidFill>
+                  <a:srgbClr val="385170"/>
+                </a:solidFill>
+                <a:effectLst/>
+                <a:uFillTx/>
+                <a:latin typeface="Calibri"/>
+              </a:rPr>
+              <a:t> internal topic</a:t>
+            </a:r>
+            <a:endParaRPr lang="en-IN" sz="1000" b="0" u="none" strike="noStrike" dirty="0">
+              <a:solidFill>
+                <a:srgbClr val="000000"/>
+              </a:solidFill>
+              <a:effectLst/>
+              <a:uFillTx/>
+              <a:latin typeface="Arial"/>
+            </a:endParaRPr>
+          </a:p>
+          <a:p>
+            <a:pPr defTabSz="914400">
+              <a:lnSpc>
+                <a:spcPct val="100000"/>
+              </a:lnSpc>
+            </a:pPr>
+            <a:r>
+              <a:rPr lang="en-US" sz="1000" b="0" u="none" strike="noStrike" dirty="0">
+                <a:solidFill>
+                  <a:srgbClr val="385170"/>
+                </a:solidFill>
+                <a:effectLst/>
+                <a:uFillTx/>
+                <a:latin typeface="Calibri"/>
+              </a:rPr>
               <a:t>b) Each partition log</a:t>
             </a:r>
-            <a:endParaRPr lang="en-IN" sz="1000" b="0" u="none" strike="noStrike">
-              <a:solidFill>
-                <a:srgbClr val="000000"/>
-              </a:solidFill>
-              <a:effectLst/>
-              <a:uFillTx/>
-              <a:latin typeface="Arial"/>
-            </a:endParaRPr>
-          </a:p>
-          <a:p>
-            <a:pPr defTabSz="914400">
-              <a:lnSpc>
-                <a:spcPct val="100000"/>
-              </a:lnSpc>
-            </a:pPr>
-            <a:r>
-              <a:rPr lang="en-US" sz="1000" b="0" u="none" strike="noStrike">
+            <a:endParaRPr lang="en-IN" sz="1000" b="0" u="none" strike="noStrike" dirty="0">
+              <a:solidFill>
+                <a:srgbClr val="000000"/>
+              </a:solidFill>
+              <a:effectLst/>
+              <a:uFillTx/>
+              <a:latin typeface="Arial"/>
+            </a:endParaRPr>
+          </a:p>
+          <a:p>
+            <a:pPr defTabSz="914400">
+              <a:lnSpc>
+                <a:spcPct val="100000"/>
+              </a:lnSpc>
+            </a:pPr>
+            <a:r>
+              <a:rPr lang="en-US" sz="1000" b="0" u="none" strike="noStrike" dirty="0">
                 <a:solidFill>
                   <a:srgbClr val="385170"/>
                 </a:solidFill>
@@ -21258,23 +21393,23 @@
               </a:rPr>
               <a:t>c) An external database</a:t>
             </a:r>
-            <a:endParaRPr lang="en-IN" sz="1000" b="0" u="none" strike="noStrike">
-              <a:solidFill>
-                <a:srgbClr val="000000"/>
-              </a:solidFill>
-              <a:effectLst/>
-              <a:uFillTx/>
-              <a:latin typeface="Arial"/>
-            </a:endParaRPr>
-          </a:p>
-          <a:p>
-            <a:pPr defTabSz="914400">
-              <a:lnSpc>
-                <a:spcPct val="100000"/>
-              </a:lnSpc>
-            </a:pPr>
-            <a:r>
-              <a:rPr lang="en-US" sz="1000" b="0" u="none" strike="noStrike">
+            <a:endParaRPr lang="en-IN" sz="1000" b="0" u="none" strike="noStrike" dirty="0">
+              <a:solidFill>
+                <a:srgbClr val="000000"/>
+              </a:solidFill>
+              <a:effectLst/>
+              <a:uFillTx/>
+              <a:latin typeface="Arial"/>
+            </a:endParaRPr>
+          </a:p>
+          <a:p>
+            <a:pPr defTabSz="914400">
+              <a:lnSpc>
+                <a:spcPct val="100000"/>
+              </a:lnSpc>
+            </a:pPr>
+            <a:r>
+              <a:rPr lang="en-US" sz="1000" b="0" u="none" strike="noStrike" dirty="0">
                 <a:solidFill>
                   <a:srgbClr val="385170"/>
                 </a:solidFill>
@@ -21284,38 +21419,38 @@
               </a:rPr>
               <a:t>d) Zookeeper</a:t>
             </a:r>
-            <a:endParaRPr lang="en-IN" sz="1000" b="0" u="none" strike="noStrike">
-              <a:solidFill>
-                <a:srgbClr val="000000"/>
-              </a:solidFill>
-              <a:effectLst/>
-              <a:uFillTx/>
-              <a:latin typeface="Arial"/>
-            </a:endParaRPr>
-          </a:p>
-          <a:p>
-            <a:pPr defTabSz="914400">
-              <a:lnSpc>
-                <a:spcPct val="100000"/>
-              </a:lnSpc>
-            </a:pPr>
-            <a:endParaRPr lang="en-IN" sz="1000" b="0" u="none" strike="noStrike">
-              <a:solidFill>
-                <a:srgbClr val="000000"/>
-              </a:solidFill>
-              <a:effectLst/>
-              <a:uFillTx/>
-              <a:latin typeface="Arial"/>
-            </a:endParaRPr>
-          </a:p>
-          <a:p>
-            <a:pPr defTabSz="914400">
-              <a:lnSpc>
-                <a:spcPct val="100000"/>
-              </a:lnSpc>
-            </a:pPr>
-            <a:r>
-              <a:rPr lang="en-US" sz="1100" b="1" u="none" strike="noStrike">
+            <a:endParaRPr lang="en-IN" sz="1000" b="0" u="none" strike="noStrike" dirty="0">
+              <a:solidFill>
+                <a:srgbClr val="000000"/>
+              </a:solidFill>
+              <a:effectLst/>
+              <a:uFillTx/>
+              <a:latin typeface="Arial"/>
+            </a:endParaRPr>
+          </a:p>
+          <a:p>
+            <a:pPr defTabSz="914400">
+              <a:lnSpc>
+                <a:spcPct val="100000"/>
+              </a:lnSpc>
+            </a:pPr>
+            <a:endParaRPr lang="en-IN" sz="1000" b="0" u="none" strike="noStrike" dirty="0">
+              <a:solidFill>
+                <a:srgbClr val="000000"/>
+              </a:solidFill>
+              <a:effectLst/>
+              <a:uFillTx/>
+              <a:latin typeface="Arial"/>
+            </a:endParaRPr>
+          </a:p>
+          <a:p>
+            <a:pPr defTabSz="914400">
+              <a:lnSpc>
+                <a:spcPct val="100000"/>
+              </a:lnSpc>
+            </a:pPr>
+            <a:r>
+              <a:rPr lang="en-US" sz="1100" b="1" u="none" strike="noStrike" dirty="0">
                 <a:solidFill>
                   <a:srgbClr val="2F5597"/>
                 </a:solidFill>
@@ -21325,7 +21460,7 @@
               </a:rPr>
               <a:t>Q4. Which setting controls where a new consumer group starts reading?</a:t>
             </a:r>
-            <a:endParaRPr lang="en-IN" sz="1100" b="0" u="none" strike="noStrike">
+            <a:endParaRPr lang="en-IN" sz="1100" b="0" u="none" strike="noStrike" dirty="0">
               <a:solidFill>
                 <a:srgbClr val="000000"/>
               </a:solidFill>
@@ -21344,7 +21479,7 @@
               </a:tabLst>
             </a:pPr>
             <a:r>
-              <a:rPr lang="en-US" sz="1000" b="0" u="none" strike="noStrike">
+              <a:rPr lang="en-US" sz="1000" b="0" u="none" strike="noStrike" dirty="0">
                 <a:solidFill>
                   <a:srgbClr val="385170"/>
                 </a:solidFill>
@@ -21352,9 +21487,20 @@
                 <a:uFillTx/>
                 <a:latin typeface="Calibri"/>
               </a:rPr>
-              <a:t>a) enable.auto.commit</a:t>
-            </a:r>
-            <a:endParaRPr lang="en-IN" sz="1000" b="0" u="none" strike="noStrike">
+              <a:t>a) </a:t>
+            </a:r>
+            <a:r>
+              <a:rPr lang="en-US" sz="1000" b="0" u="none" strike="noStrike" dirty="0" err="1">
+                <a:solidFill>
+                  <a:srgbClr val="385170"/>
+                </a:solidFill>
+                <a:effectLst/>
+                <a:uFillTx/>
+                <a:latin typeface="Calibri"/>
+              </a:rPr>
+              <a:t>enable.auto.commit</a:t>
+            </a:r>
+            <a:endParaRPr lang="en-IN" sz="1000" b="0" u="none" strike="noStrike" dirty="0">
               <a:solidFill>
                 <a:srgbClr val="000000"/>
               </a:solidFill>
@@ -21373,7 +21519,7 @@
               </a:tabLst>
             </a:pPr>
             <a:r>
-              <a:rPr lang="en-US" sz="1000" b="0" u="none" strike="noStrike">
+              <a:rPr lang="en-US" sz="1000" b="0" u="none" strike="noStrike" dirty="0">
                 <a:solidFill>
                   <a:srgbClr val="385170"/>
                 </a:solidFill>
@@ -21381,9 +21527,20 @@
                 <a:uFillTx/>
                 <a:latin typeface="Calibri"/>
               </a:rPr>
-              <a:t>b) auto.offset.reset</a:t>
-            </a:r>
-            <a:endParaRPr lang="en-IN" sz="1000" b="0" u="none" strike="noStrike">
+              <a:t>b) </a:t>
+            </a:r>
+            <a:r>
+              <a:rPr lang="en-US" sz="1000" b="0" u="none" strike="noStrike" dirty="0" err="1">
+                <a:solidFill>
+                  <a:srgbClr val="385170"/>
+                </a:solidFill>
+                <a:effectLst/>
+                <a:uFillTx/>
+                <a:latin typeface="Calibri"/>
+              </a:rPr>
+              <a:t>auto.offset.reset</a:t>
+            </a:r>
+            <a:endParaRPr lang="en-IN" sz="1000" b="0" u="none" strike="noStrike" dirty="0">
               <a:solidFill>
                 <a:srgbClr val="000000"/>
               </a:solidFill>
@@ -21402,7 +21559,7 @@
               </a:tabLst>
             </a:pPr>
             <a:r>
-              <a:rPr lang="en-US" sz="1000" b="0" u="none" strike="noStrike">
+              <a:rPr lang="en-US" sz="1000" b="0" u="none" strike="noStrike" dirty="0">
                 <a:solidFill>
                   <a:srgbClr val="385170"/>
                 </a:solidFill>
@@ -21412,7 +21569,7 @@
               </a:rPr>
               <a:t>c) session.timeout.ms</a:t>
             </a:r>
-            <a:endParaRPr lang="en-IN" sz="1000" b="0" u="none" strike="noStrike">
+            <a:endParaRPr lang="en-IN" sz="1000" b="0" u="none" strike="noStrike" dirty="0">
               <a:solidFill>
                 <a:srgbClr val="000000"/>
               </a:solidFill>
@@ -21431,7 +21588,7 @@
               </a:tabLst>
             </a:pPr>
             <a:r>
-              <a:rPr lang="en-US" sz="1000" b="0" u="none" strike="noStrike">
+              <a:rPr lang="en-US" sz="1000" b="0" u="none" strike="noStrike" dirty="0">
                 <a:solidFill>
                   <a:srgbClr val="385170"/>
                 </a:solidFill>
@@ -21439,9 +21596,20 @@
                 <a:uFillTx/>
                 <a:latin typeface="Calibri"/>
               </a:rPr>
-              <a:t>d) max.poll.records</a:t>
-            </a:r>
-            <a:endParaRPr lang="en-IN" sz="1000" b="0" u="none" strike="noStrike">
+              <a:t>d) </a:t>
+            </a:r>
+            <a:r>
+              <a:rPr lang="en-US" sz="1000" b="0" u="none" strike="noStrike" dirty="0" err="1">
+                <a:solidFill>
+                  <a:srgbClr val="385170"/>
+                </a:solidFill>
+                <a:effectLst/>
+                <a:uFillTx/>
+                <a:latin typeface="Calibri"/>
+              </a:rPr>
+              <a:t>max.poll.records</a:t>
+            </a:r>
+            <a:endParaRPr lang="en-IN" sz="1000" b="0" u="none" strike="noStrike" dirty="0">
               <a:solidFill>
                 <a:srgbClr val="000000"/>
               </a:solidFill>
@@ -22964,7 +23132,7 @@
         <p:spPr>
           <a:xfrm>
             <a:off x="341630" y="886943"/>
-            <a:ext cx="7406280" cy="4261320"/>
+            <a:ext cx="7406280" cy="2373555"/>
           </a:xfrm>
           <a:prstGeom prst="rect">
             <a:avLst/>
@@ -23151,272 +23319,198 @@
               </a:rPr>
               <a:t>Resetting offsets is useful for replay, but replay can repeat downstream side effects.</a:t>
             </a:r>
-            <a:endParaRPr lang="en-IN" sz="900" b="0" u="none" strike="noStrike" dirty="0">
-              <a:solidFill>
-                <a:srgbClr val="000000"/>
-              </a:solidFill>
-              <a:effectLst/>
-              <a:uFillTx/>
-              <a:latin typeface="Arial"/>
-            </a:endParaRPr>
-          </a:p>
-          <a:p>
-            <a:pPr defTabSz="914400">
-              <a:lnSpc>
-                <a:spcPct val="100000"/>
-              </a:lnSpc>
-              <a:spcBef>
-                <a:spcPts val="1191"/>
-              </a:spcBef>
+          </a:p>
+          <a:p>
+            <a:pPr marL="343080" indent="-171360" defTabSz="914400">
+              <a:lnSpc>
+                <a:spcPct val="100000"/>
+              </a:lnSpc>
               <a:spcAft>
-                <a:spcPts val="992"/>
+                <a:spcPts val="601"/>
               </a:spcAft>
-            </a:pPr>
-            <a:r>
-              <a:rPr lang="en-US" sz="900" b="0" u="none" strike="noStrike" dirty="0">
-                <a:solidFill>
-                  <a:srgbClr val="1E1E1E"/>
-                </a:solidFill>
-                <a:effectLst/>
-                <a:uFillTx/>
-                <a:latin typeface="Calibri"/>
-              </a:rPr>
-              <a:t>Q5. With RF=3 and </a:t>
-            </a:r>
-            <a:r>
-              <a:rPr lang="en-US" sz="900" b="0" u="none" strike="noStrike" dirty="0" err="1">
-                <a:solidFill>
-                  <a:srgbClr val="1E1E1E"/>
-                </a:solidFill>
-                <a:effectLst/>
-                <a:uFillTx/>
-                <a:latin typeface="Calibri"/>
-              </a:rPr>
-              <a:t>min.insync.replicas</a:t>
-            </a:r>
-            <a:r>
-              <a:rPr lang="en-US" sz="900" b="0" u="none" strike="noStrike" dirty="0">
-                <a:solidFill>
-                  <a:srgbClr val="1E1E1E"/>
-                </a:solidFill>
-                <a:effectLst/>
-                <a:uFillTx/>
-                <a:latin typeface="Calibri"/>
-              </a:rPr>
-              <a:t>=2, how many broker failures can you tolerate without losing write availability?</a:t>
-            </a:r>
-            <a:endParaRPr lang="en-IN" sz="900" b="0" u="none" strike="noStrike" dirty="0">
-              <a:solidFill>
-                <a:srgbClr val="000000"/>
-              </a:solidFill>
-              <a:effectLst/>
-              <a:uFillTx/>
-              <a:latin typeface="Arial"/>
-            </a:endParaRPr>
-          </a:p>
-          <a:p>
-            <a:pPr defTabSz="914400">
-              <a:lnSpc>
-                <a:spcPct val="100000"/>
-              </a:lnSpc>
-              <a:spcBef>
-                <a:spcPts val="1191"/>
-              </a:spcBef>
+              <a:buClr>
+                <a:srgbClr val="1E1E1E"/>
+              </a:buClr>
+              <a:buFont typeface="Symbol" charset="2"/>
+              <a:buChar char=""/>
+            </a:pPr>
+            <a:r>
+              <a:rPr lang="en-IN" sz="900" b="0" u="none" strike="noStrike" dirty="0">
+                <a:solidFill>
+                  <a:srgbClr val="000000"/>
+                </a:solidFill>
+                <a:effectLst/>
+                <a:uFillTx/>
+                <a:latin typeface="Arial"/>
+              </a:rPr>
+              <a:t>Q3. Where are committed offsets stored?</a:t>
+            </a:r>
+          </a:p>
+          <a:p>
+            <a:pPr marL="343080" indent="-171360" defTabSz="914400">
+              <a:lnSpc>
+                <a:spcPct val="100000"/>
+              </a:lnSpc>
               <a:spcAft>
-                <a:spcPts val="992"/>
+                <a:spcPts val="601"/>
               </a:spcAft>
-            </a:pPr>
-            <a:r>
-              <a:rPr lang="en-US" sz="900" b="0" u="none" strike="noStrike" dirty="0">
-                <a:solidFill>
-                  <a:srgbClr val="1E1E1E"/>
-                </a:solidFill>
-                <a:effectLst/>
-                <a:uFillTx/>
-                <a:latin typeface="Calibri"/>
-              </a:rPr>
-              <a:t>Answer: b) 1</a:t>
-            </a:r>
-            <a:endParaRPr lang="en-IN" sz="900" b="0" u="none" strike="noStrike" dirty="0">
-              <a:solidFill>
-                <a:srgbClr val="000000"/>
-              </a:solidFill>
-              <a:effectLst/>
-              <a:uFillTx/>
-              <a:latin typeface="Arial"/>
-            </a:endParaRPr>
-          </a:p>
-          <a:p>
-            <a:pPr defTabSz="914400">
-              <a:lnSpc>
-                <a:spcPct val="100000"/>
-              </a:lnSpc>
-              <a:spcBef>
-                <a:spcPts val="1191"/>
-              </a:spcBef>
+              <a:buClr>
+                <a:srgbClr val="1E1E1E"/>
+              </a:buClr>
+              <a:buFont typeface="Symbol" charset="2"/>
+              <a:buChar char=""/>
+            </a:pPr>
+            <a:r>
+              <a:rPr lang="en-IN" sz="900" b="0" u="none" strike="noStrike" dirty="0">
+                <a:solidFill>
+                  <a:srgbClr val="000000"/>
+                </a:solidFill>
+                <a:effectLst/>
+                <a:uFillTx/>
+                <a:latin typeface="Arial"/>
+              </a:rPr>
+              <a:t>a) __</a:t>
+            </a:r>
+            <a:r>
+              <a:rPr lang="en-IN" sz="900" b="0" u="none" strike="noStrike" dirty="0" err="1">
+                <a:solidFill>
+                  <a:srgbClr val="000000"/>
+                </a:solidFill>
+                <a:effectLst/>
+                <a:uFillTx/>
+                <a:latin typeface="Arial"/>
+              </a:rPr>
+              <a:t>consumer_offsets</a:t>
+            </a:r>
+            <a:r>
+              <a:rPr lang="en-IN" sz="900" b="0" u="none" strike="noStrike" dirty="0">
+                <a:solidFill>
+                  <a:srgbClr val="000000"/>
+                </a:solidFill>
+                <a:effectLst/>
+                <a:uFillTx/>
+                <a:latin typeface="Arial"/>
+              </a:rPr>
+              <a:t> internal </a:t>
+            </a:r>
+            <a:r>
+              <a:rPr lang="en-IN" sz="900" b="0" u="none" strike="noStrike" dirty="0" err="1">
+                <a:solidFill>
+                  <a:srgbClr val="000000"/>
+                </a:solidFill>
+                <a:effectLst/>
+                <a:uFillTx/>
+                <a:latin typeface="Arial"/>
+              </a:rPr>
+              <a:t>topicKafka</a:t>
+            </a:r>
+            <a:r>
+              <a:rPr lang="en-IN" sz="900" b="0" u="none" strike="noStrike" dirty="0">
+                <a:solidFill>
+                  <a:srgbClr val="000000"/>
+                </a:solidFill>
+                <a:effectLst/>
+                <a:uFillTx/>
+                <a:latin typeface="Arial"/>
+              </a:rPr>
+              <a:t> stores committed consumer offsets in the internal Kafka topic called __</a:t>
+            </a:r>
+            <a:r>
+              <a:rPr lang="en-IN" sz="900" b="0" u="none" strike="noStrike" dirty="0" err="1">
+                <a:solidFill>
+                  <a:srgbClr val="000000"/>
+                </a:solidFill>
+                <a:effectLst/>
+                <a:uFillTx/>
+                <a:latin typeface="Arial"/>
+              </a:rPr>
+              <a:t>consumer_offsets</a:t>
+            </a:r>
+            <a:r>
+              <a:rPr lang="en-IN" sz="900" b="0" u="none" strike="noStrike" dirty="0">
+                <a:solidFill>
+                  <a:srgbClr val="000000"/>
+                </a:solidFill>
+                <a:effectLst/>
+                <a:uFillTx/>
+                <a:latin typeface="Arial"/>
+              </a:rPr>
+              <a:t>.</a:t>
+            </a:r>
+          </a:p>
+          <a:p>
+            <a:pPr marL="343080" indent="-171360" defTabSz="914400">
+              <a:lnSpc>
+                <a:spcPct val="100000"/>
+              </a:lnSpc>
               <a:spcAft>
-                <a:spcPts val="992"/>
+                <a:spcPts val="601"/>
               </a:spcAft>
-            </a:pPr>
-            <a:r>
-              <a:rPr lang="en-US" sz="900" b="0" u="none" strike="noStrike" dirty="0">
-                <a:solidFill>
-                  <a:srgbClr val="1E1E1E"/>
-                </a:solidFill>
-                <a:effectLst/>
-                <a:uFillTx/>
-                <a:latin typeface="Calibri"/>
-              </a:rPr>
-              <a:t>With replication factor 3, there are 3 replicas. With </a:t>
-            </a:r>
-            <a:r>
-              <a:rPr lang="en-US" sz="900" b="0" u="none" strike="noStrike" dirty="0" err="1">
-                <a:solidFill>
-                  <a:srgbClr val="1E1E1E"/>
-                </a:solidFill>
-                <a:effectLst/>
-                <a:uFillTx/>
-                <a:latin typeface="Calibri"/>
-              </a:rPr>
-              <a:t>min.insync.replicas</a:t>
-            </a:r>
-            <a:r>
-              <a:rPr lang="en-US" sz="900" b="0" u="none" strike="noStrike" dirty="0">
-                <a:solidFill>
-                  <a:srgbClr val="1E1E1E"/>
-                </a:solidFill>
-                <a:effectLst/>
-                <a:uFillTx/>
-                <a:latin typeface="Calibri"/>
-              </a:rPr>
-              <a:t>=2, Kafka needs at least 2 in-sync replicas available to accept writes when producer acks=all is used. So you can lose 1 broker and still continue writing.</a:t>
-            </a:r>
-            <a:endParaRPr lang="en-IN" sz="900" b="0" u="none" strike="noStrike" dirty="0">
-              <a:solidFill>
-                <a:srgbClr val="000000"/>
-              </a:solidFill>
-              <a:effectLst/>
-              <a:uFillTx/>
-              <a:latin typeface="Arial"/>
-            </a:endParaRPr>
-          </a:p>
-          <a:p>
-            <a:pPr defTabSz="914400">
-              <a:lnSpc>
-                <a:spcPct val="100000"/>
-              </a:lnSpc>
-              <a:spcBef>
-                <a:spcPts val="1191"/>
-              </a:spcBef>
+              <a:buClr>
+                <a:srgbClr val="1E1E1E"/>
+              </a:buClr>
+              <a:buFont typeface="Symbol" charset="2"/>
+              <a:buChar char=""/>
+            </a:pPr>
+            <a:r>
+              <a:rPr lang="en-IN" sz="900" b="0" u="none" strike="noStrike" dirty="0">
+                <a:solidFill>
+                  <a:srgbClr val="000000"/>
+                </a:solidFill>
+                <a:effectLst/>
+                <a:uFillTx/>
+                <a:latin typeface="Arial"/>
+              </a:rPr>
+              <a:t>Q4. Which setting controls where a new consumer group starts reading?</a:t>
+            </a:r>
+          </a:p>
+          <a:p>
+            <a:pPr marL="343080" indent="-171360" defTabSz="914400">
+              <a:lnSpc>
+                <a:spcPct val="100000"/>
+              </a:lnSpc>
               <a:spcAft>
-                <a:spcPts val="992"/>
+                <a:spcPts val="601"/>
               </a:spcAft>
-            </a:pPr>
-            <a:r>
-              <a:rPr lang="en-US" sz="900" b="0" u="none" strike="noStrike" dirty="0">
-                <a:solidFill>
-                  <a:srgbClr val="1E1E1E"/>
-                </a:solidFill>
-                <a:effectLst/>
-                <a:uFillTx/>
-                <a:latin typeface="Calibri"/>
-              </a:rPr>
-              <a:t>Q6. What is the effect of setting </a:t>
-            </a:r>
-            <a:r>
-              <a:rPr lang="en-US" sz="900" b="0" u="none" strike="noStrike" dirty="0" err="1">
-                <a:solidFill>
-                  <a:srgbClr val="1E1E1E"/>
-                </a:solidFill>
-                <a:effectLst/>
-                <a:uFillTx/>
-                <a:latin typeface="Calibri"/>
-              </a:rPr>
-              <a:t>unclean.leader.election.enable</a:t>
-            </a:r>
-            <a:r>
-              <a:rPr lang="en-US" sz="900" b="0" u="none" strike="noStrike" dirty="0">
-                <a:solidFill>
-                  <a:srgbClr val="1E1E1E"/>
-                </a:solidFill>
-                <a:effectLst/>
-                <a:uFillTx/>
-                <a:latin typeface="Calibri"/>
-              </a:rPr>
-              <a:t>=true?</a:t>
-            </a:r>
-            <a:endParaRPr lang="en-IN" sz="900" b="0" u="none" strike="noStrike" dirty="0">
-              <a:solidFill>
-                <a:srgbClr val="000000"/>
-              </a:solidFill>
-              <a:effectLst/>
-              <a:uFillTx/>
-              <a:latin typeface="Arial"/>
-            </a:endParaRPr>
-          </a:p>
-          <a:p>
-            <a:pPr defTabSz="914400">
-              <a:lnSpc>
-                <a:spcPct val="100000"/>
-              </a:lnSpc>
-              <a:spcBef>
-                <a:spcPts val="1191"/>
-              </a:spcBef>
-              <a:spcAft>
-                <a:spcPts val="992"/>
-              </a:spcAft>
-            </a:pPr>
-            <a:r>
-              <a:rPr lang="en-US" sz="900" b="0" u="none" strike="noStrike" dirty="0">
-                <a:solidFill>
-                  <a:srgbClr val="1E1E1E"/>
-                </a:solidFill>
-                <a:effectLst/>
-                <a:uFillTx/>
-                <a:latin typeface="Calibri"/>
-              </a:rPr>
-              <a:t>Answer: b) Faster failover; non-ISR replicas can become leader risking data loss</a:t>
-            </a:r>
-            <a:endParaRPr lang="en-IN" sz="900" b="0" u="none" strike="noStrike" dirty="0">
-              <a:solidFill>
-                <a:srgbClr val="000000"/>
-              </a:solidFill>
-              <a:effectLst/>
-              <a:uFillTx/>
-              <a:latin typeface="Arial"/>
-            </a:endParaRPr>
-          </a:p>
-          <a:p>
-            <a:pPr defTabSz="914400">
-              <a:lnSpc>
-                <a:spcPct val="100000"/>
-              </a:lnSpc>
-              <a:spcBef>
-                <a:spcPts val="1191"/>
-              </a:spcBef>
-              <a:spcAft>
-                <a:spcPts val="992"/>
-              </a:spcAft>
-            </a:pPr>
-            <a:r>
-              <a:rPr lang="en-US" sz="900" b="0" u="none" strike="noStrike" dirty="0">
-                <a:solidFill>
-                  <a:srgbClr val="1E1E1E"/>
-                </a:solidFill>
-                <a:effectLst/>
-                <a:uFillTx/>
-                <a:latin typeface="Calibri"/>
-              </a:rPr>
-              <a:t>This setting allows Kafka to elect a replica that is not in the ISR as leader. It can restore availability faster, but it may lose messages that were not replicated to that out-of-sync replica.</a:t>
-            </a:r>
-            <a:endParaRPr lang="en-IN" sz="900" b="0" u="none" strike="noStrike" dirty="0">
-              <a:solidFill>
-                <a:srgbClr val="000000"/>
-              </a:solidFill>
-              <a:effectLst/>
-              <a:uFillTx/>
-              <a:latin typeface="Arial"/>
-            </a:endParaRPr>
+              <a:buClr>
+                <a:srgbClr val="1E1E1E"/>
+              </a:buClr>
+              <a:buFont typeface="Symbol" charset="2"/>
+              <a:buChar char=""/>
+            </a:pPr>
+            <a:r>
+              <a:rPr lang="en-IN" sz="900" b="0" u="none" strike="noStrike" dirty="0">
+                <a:solidFill>
+                  <a:srgbClr val="000000"/>
+                </a:solidFill>
+                <a:effectLst/>
+                <a:uFillTx/>
+                <a:latin typeface="Arial"/>
+              </a:rPr>
+              <a:t> b) </a:t>
+            </a:r>
+            <a:r>
+              <a:rPr lang="en-IN" sz="900" b="0" u="none" strike="noStrike" dirty="0" err="1">
+                <a:solidFill>
+                  <a:srgbClr val="000000"/>
+                </a:solidFill>
+                <a:effectLst/>
+                <a:uFillTx/>
+                <a:latin typeface="Arial"/>
+              </a:rPr>
+              <a:t>auto.offset.resetauto.offset.reset</a:t>
+            </a:r>
+            <a:r>
+              <a:rPr lang="en-IN" sz="900" b="0" u="none" strike="noStrike" dirty="0">
+                <a:solidFill>
+                  <a:srgbClr val="000000"/>
+                </a:solidFill>
+                <a:effectLst/>
+                <a:uFillTx/>
+                <a:latin typeface="Arial"/>
+              </a:rPr>
+              <a:t> decides where a consumer starts when there is no committed offset for that consumer group.</a:t>
+            </a:r>
           </a:p>
           <a:p>
             <a:pPr defTabSz="914400">
@@ -29393,8 +29487,8 @@
         </p:nvSpPr>
         <p:spPr>
           <a:xfrm>
-            <a:off x="640080" y="1234440"/>
-            <a:ext cx="7406280" cy="1812240"/>
+            <a:off x="515036" y="960903"/>
+            <a:ext cx="7406280" cy="4322807"/>
           </a:xfrm>
           <a:prstGeom prst="rect">
             <a:avLst/>
@@ -29436,7 +29530,7 @@
               <a:buChar char=""/>
             </a:pPr>
             <a:r>
-              <a:rPr lang="en-US" sz="1500" b="0" u="none" strike="noStrike">
+              <a:rPr lang="en-US" sz="900" b="0" u="none" strike="noStrike" dirty="0">
                 <a:solidFill>
                   <a:srgbClr val="1E1E1E"/>
                 </a:solidFill>
@@ -29444,9 +29538,31 @@
                 <a:uFillTx/>
                 <a:latin typeface="Calibri"/>
               </a:rPr>
-              <a:t>With RF=3 and min.insync.replicas=2, Kafka can usually tolerate one broker failure for acks=all writes.</a:t>
-            </a:r>
-            <a:endParaRPr lang="en-IN" sz="1500" b="0" u="none" strike="noStrike">
+              <a:t>With RF=3 and </a:t>
+            </a:r>
+            <a:r>
+              <a:rPr lang="en-US" sz="900" b="0" u="none" strike="noStrike" dirty="0" err="1">
+                <a:solidFill>
+                  <a:srgbClr val="1E1E1E"/>
+                </a:solidFill>
+                <a:effectLst/>
+                <a:uFillTx/>
+                <a:latin typeface="Calibri"/>
+              </a:rPr>
+              <a:t>min.insync.replicas</a:t>
+            </a:r>
+            <a:r>
+              <a:rPr lang="en-US" sz="900" b="0" u="none" strike="noStrike" dirty="0">
+                <a:solidFill>
+                  <a:srgbClr val="1E1E1E"/>
+                </a:solidFill>
+                <a:effectLst/>
+                <a:uFillTx/>
+                <a:latin typeface="Calibri"/>
+              </a:rPr>
+              <a:t>=2, Kafka can usually tolerate one broker failure for acks=all writes.</a:t>
+            </a:r>
+            <a:endParaRPr lang="en-IN" sz="900" b="0" u="none" strike="noStrike" dirty="0">
               <a:solidFill>
                 <a:srgbClr val="000000"/>
               </a:solidFill>
@@ -29470,7 +29586,7 @@
               <a:buChar char=""/>
             </a:pPr>
             <a:r>
-              <a:rPr lang="en-US" sz="1500" b="0" u="none" strike="noStrike">
+              <a:rPr lang="en-US" sz="900" b="0" u="none" strike="noStrike" dirty="0">
                 <a:solidFill>
                   <a:srgbClr val="1E1E1E"/>
                 </a:solidFill>
@@ -29480,7 +29596,7 @@
               </a:rPr>
               <a:t>The leader handles client traffic; followers replicate from the leader.</a:t>
             </a:r>
-            <a:endParaRPr lang="en-IN" sz="1500" b="0" u="none" strike="noStrike">
+            <a:endParaRPr lang="en-IN" sz="900" b="0" u="none" strike="noStrike" dirty="0">
               <a:solidFill>
                 <a:srgbClr val="000000"/>
               </a:solidFill>
@@ -29504,7 +29620,7 @@
               <a:buChar char=""/>
             </a:pPr>
             <a:r>
-              <a:rPr lang="en-US" sz="1500" b="0" u="none" strike="noStrike">
+              <a:rPr lang="en-US" sz="900" b="0" u="none" strike="noStrike" dirty="0">
                 <a:solidFill>
                   <a:srgbClr val="1E1E1E"/>
                 </a:solidFill>
@@ -29514,7 +29630,7 @@
               </a:rPr>
               <a:t>Only in-sync replicas are safe candidates for clean leadership.</a:t>
             </a:r>
-            <a:endParaRPr lang="en-IN" sz="1500" b="0" u="none" strike="noStrike">
+            <a:endParaRPr lang="en-IN" sz="900" b="0" u="none" strike="noStrike" dirty="0">
               <a:solidFill>
                 <a:srgbClr val="000000"/>
               </a:solidFill>
@@ -29538,7 +29654,7 @@
               <a:buChar char=""/>
             </a:pPr>
             <a:r>
-              <a:rPr lang="en-US" sz="1500" b="0" u="none" strike="noStrike">
+              <a:rPr lang="en-US" sz="900" b="0" u="none" strike="noStrike" dirty="0" err="1">
                 <a:solidFill>
                   <a:srgbClr val="1E1E1E"/>
                 </a:solidFill>
@@ -29546,27 +29662,288 @@
                 <a:uFillTx/>
                 <a:latin typeface="Calibri"/>
               </a:rPr>
-              <a:t>KRaft manages metadata and leader election without ZooKeeper.</a:t>
-            </a:r>
-            <a:endParaRPr lang="en-IN" sz="1500" b="0" u="none" strike="noStrike">
-              <a:solidFill>
-                <a:srgbClr val="000000"/>
-              </a:solidFill>
-              <a:effectLst/>
-              <a:uFillTx/>
-              <a:latin typeface="Arial"/>
-            </a:endParaRPr>
-          </a:p>
-          <a:p>
-            <a:pPr defTabSz="914400">
+              <a:t>KRaft</a:t>
+            </a:r>
+            <a:r>
+              <a:rPr lang="en-US" sz="900" b="0" u="none" strike="noStrike" dirty="0">
+                <a:solidFill>
+                  <a:srgbClr val="1E1E1E"/>
+                </a:solidFill>
+                <a:effectLst/>
+                <a:uFillTx/>
+                <a:latin typeface="Calibri"/>
+              </a:rPr>
+              <a:t> manages metadata and leader election without </a:t>
+            </a:r>
+            <a:r>
+              <a:rPr lang="en-US" sz="900" b="0" u="none" strike="noStrike" dirty="0" err="1">
+                <a:solidFill>
+                  <a:srgbClr val="1E1E1E"/>
+                </a:solidFill>
+                <a:effectLst/>
+                <a:uFillTx/>
+                <a:latin typeface="Calibri"/>
+              </a:rPr>
+              <a:t>ZooKeeper</a:t>
+            </a:r>
+            <a:r>
+              <a:rPr lang="en-US" sz="900" b="0" u="none" strike="noStrike" dirty="0">
+                <a:solidFill>
+                  <a:srgbClr val="1E1E1E"/>
+                </a:solidFill>
+                <a:effectLst/>
+                <a:uFillTx/>
+                <a:latin typeface="Calibri"/>
+              </a:rPr>
+              <a:t>.</a:t>
+            </a:r>
+          </a:p>
+          <a:p>
+            <a:pPr marL="343080" indent="-171360" defTabSz="914400">
               <a:lnSpc>
                 <a:spcPct val="100000"/>
               </a:lnSpc>
               <a:spcAft>
                 <a:spcPts val="601"/>
               </a:spcAft>
-            </a:pPr>
-            <a:endParaRPr lang="en-IN" sz="1800" b="0" u="none" strike="noStrike">
+              <a:buClr>
+                <a:srgbClr val="1E1E1E"/>
+              </a:buClr>
+              <a:buFont typeface="Symbol" charset="2"/>
+              <a:buChar char=""/>
+            </a:pPr>
+            <a:endParaRPr lang="en-US" sz="900" dirty="0">
+              <a:solidFill>
+                <a:srgbClr val="1E1E1E"/>
+              </a:solidFill>
+              <a:latin typeface="Calibri"/>
+            </a:endParaRPr>
+          </a:p>
+          <a:p>
+            <a:pPr>
+              <a:spcBef>
+                <a:spcPts val="1191"/>
+              </a:spcBef>
+              <a:spcAft>
+                <a:spcPts val="992"/>
+              </a:spcAft>
+            </a:pPr>
+            <a:r>
+              <a:rPr lang="en-US" sz="900" dirty="0">
+                <a:solidFill>
+                  <a:srgbClr val="1E1E1E"/>
+                </a:solidFill>
+              </a:rPr>
+              <a:t>Q5. With RF=3 and </a:t>
+            </a:r>
+            <a:r>
+              <a:rPr lang="en-US" sz="900" dirty="0" err="1">
+                <a:solidFill>
+                  <a:srgbClr val="1E1E1E"/>
+                </a:solidFill>
+              </a:rPr>
+              <a:t>min.insync.replicas</a:t>
+            </a:r>
+            <a:r>
+              <a:rPr lang="en-US" sz="900" dirty="0">
+                <a:solidFill>
+                  <a:srgbClr val="1E1E1E"/>
+                </a:solidFill>
+              </a:rPr>
+              <a:t>=2, how many broker failures can you tolerate without losing write availability?</a:t>
+            </a:r>
+            <a:endParaRPr lang="en-IN" sz="900" dirty="0">
+              <a:solidFill>
+                <a:srgbClr val="000000"/>
+              </a:solidFill>
+              <a:latin typeface="Arial"/>
+            </a:endParaRPr>
+          </a:p>
+          <a:p>
+            <a:pPr>
+              <a:spcBef>
+                <a:spcPts val="1191"/>
+              </a:spcBef>
+              <a:spcAft>
+                <a:spcPts val="992"/>
+              </a:spcAft>
+            </a:pPr>
+            <a:r>
+              <a:rPr lang="en-US" sz="900" dirty="0">
+                <a:solidFill>
+                  <a:srgbClr val="1E1E1E"/>
+                </a:solidFill>
+              </a:rPr>
+              <a:t>Answer: b) 1</a:t>
+            </a:r>
+            <a:endParaRPr lang="en-IN" sz="900" dirty="0">
+              <a:solidFill>
+                <a:srgbClr val="000000"/>
+              </a:solidFill>
+              <a:latin typeface="Arial"/>
+            </a:endParaRPr>
+          </a:p>
+          <a:p>
+            <a:pPr>
+              <a:spcBef>
+                <a:spcPts val="1191"/>
+              </a:spcBef>
+              <a:spcAft>
+                <a:spcPts val="992"/>
+              </a:spcAft>
+            </a:pPr>
+            <a:r>
+              <a:rPr lang="en-US" sz="900" dirty="0">
+                <a:solidFill>
+                  <a:srgbClr val="1E1E1E"/>
+                </a:solidFill>
+              </a:rPr>
+              <a:t>With replication factor 3, there are 3 replicas. With </a:t>
+            </a:r>
+            <a:r>
+              <a:rPr lang="en-US" sz="900" dirty="0" err="1">
+                <a:solidFill>
+                  <a:srgbClr val="1E1E1E"/>
+                </a:solidFill>
+              </a:rPr>
+              <a:t>min.insync.replicas</a:t>
+            </a:r>
+            <a:r>
+              <a:rPr lang="en-US" sz="900" dirty="0">
+                <a:solidFill>
+                  <a:srgbClr val="1E1E1E"/>
+                </a:solidFill>
+              </a:rPr>
+              <a:t>=2, Kafka needs at least 2 in-sync replicas available to accept writes when producer acks=all is used. So you can lose 1 broker and still continue writing.</a:t>
+            </a:r>
+            <a:endParaRPr lang="en-IN" sz="900" dirty="0">
+              <a:solidFill>
+                <a:srgbClr val="000000"/>
+              </a:solidFill>
+              <a:latin typeface="Arial"/>
+            </a:endParaRPr>
+          </a:p>
+          <a:p>
+            <a:pPr>
+              <a:spcBef>
+                <a:spcPts val="1191"/>
+              </a:spcBef>
+              <a:spcAft>
+                <a:spcPts val="992"/>
+              </a:spcAft>
+            </a:pPr>
+            <a:r>
+              <a:rPr lang="en-US" sz="900" dirty="0">
+                <a:solidFill>
+                  <a:srgbClr val="1E1E1E"/>
+                </a:solidFill>
+              </a:rPr>
+              <a:t>Q6. What is the effect of setting </a:t>
+            </a:r>
+            <a:r>
+              <a:rPr lang="en-US" sz="900" dirty="0" err="1">
+                <a:solidFill>
+                  <a:srgbClr val="1E1E1E"/>
+                </a:solidFill>
+              </a:rPr>
+              <a:t>unclean.leader.election.enable</a:t>
+            </a:r>
+            <a:r>
+              <a:rPr lang="en-US" sz="900" dirty="0">
+                <a:solidFill>
+                  <a:srgbClr val="1E1E1E"/>
+                </a:solidFill>
+              </a:rPr>
+              <a:t>=true?</a:t>
+            </a:r>
+            <a:endParaRPr lang="en-IN" sz="900" dirty="0">
+              <a:solidFill>
+                <a:srgbClr val="000000"/>
+              </a:solidFill>
+              <a:latin typeface="Arial"/>
+            </a:endParaRPr>
+          </a:p>
+          <a:p>
+            <a:pPr>
+              <a:spcBef>
+                <a:spcPts val="1191"/>
+              </a:spcBef>
+              <a:spcAft>
+                <a:spcPts val="992"/>
+              </a:spcAft>
+            </a:pPr>
+            <a:r>
+              <a:rPr lang="en-US" sz="900" dirty="0">
+                <a:solidFill>
+                  <a:srgbClr val="1E1E1E"/>
+                </a:solidFill>
+              </a:rPr>
+              <a:t>Answer: b) Faster failover; non-ISR replicas can become leader risking data loss</a:t>
+            </a:r>
+            <a:endParaRPr lang="en-IN" sz="900" dirty="0">
+              <a:solidFill>
+                <a:srgbClr val="000000"/>
+              </a:solidFill>
+              <a:latin typeface="Arial"/>
+            </a:endParaRPr>
+          </a:p>
+          <a:p>
+            <a:pPr>
+              <a:spcBef>
+                <a:spcPts val="1191"/>
+              </a:spcBef>
+              <a:spcAft>
+                <a:spcPts val="992"/>
+              </a:spcAft>
+            </a:pPr>
+            <a:r>
+              <a:rPr lang="en-US" sz="900" dirty="0">
+                <a:solidFill>
+                  <a:srgbClr val="1E1E1E"/>
+                </a:solidFill>
+              </a:rPr>
+              <a:t>This setting allows Kafka to elect a replica that is not in the ISR as leader. It can restore availability faster, but it may lose messages that were not replicated to that out-of-sync replica.</a:t>
+            </a:r>
+            <a:endParaRPr lang="en-IN" sz="900" dirty="0">
+              <a:solidFill>
+                <a:srgbClr val="000000"/>
+              </a:solidFill>
+              <a:latin typeface="Arial"/>
+            </a:endParaRPr>
+          </a:p>
+          <a:p>
+            <a:pPr marL="343080" indent="-171360" defTabSz="914400">
+              <a:lnSpc>
+                <a:spcPct val="100000"/>
+              </a:lnSpc>
+              <a:spcAft>
+                <a:spcPts val="601"/>
+              </a:spcAft>
+              <a:buClr>
+                <a:srgbClr val="1E1E1E"/>
+              </a:buClr>
+              <a:buFont typeface="Symbol" charset="2"/>
+              <a:buChar char=""/>
+            </a:pPr>
+            <a:endParaRPr lang="en-IN" sz="900" b="0" u="none" strike="noStrike" dirty="0">
+              <a:solidFill>
+                <a:srgbClr val="000000"/>
+              </a:solidFill>
+              <a:effectLst/>
+              <a:uFillTx/>
+              <a:latin typeface="Arial"/>
+            </a:endParaRPr>
+          </a:p>
+          <a:p>
+            <a:pPr defTabSz="914400">
+              <a:lnSpc>
+                <a:spcPct val="100000"/>
+              </a:lnSpc>
+              <a:spcAft>
+                <a:spcPts val="601"/>
+              </a:spcAft>
+            </a:pPr>
+            <a:endParaRPr lang="en-IN" sz="900" b="0" u="none" strike="noStrike" dirty="0">
               <a:solidFill>
                 <a:srgbClr val="000000"/>
               </a:solidFill>

</xml_diff>